<commit_message>
Deck: remove footer text and slide number from all slides
Co-Authored-By: Claude Opus 5.5 <noreply@anthropic.com>
</commit_message>
<xml_diff>
--- a/presentation/PCAP_NBody_Adaptive_Scheduling.pptx
+++ b/presentation/PCAP_NBody_Adaptive_Scheduling.pptx
@@ -128,40 +128,40 @@
   <p:extLst>
     <p:ext uri="{521415D9-36F7-43E2-AB2F-B90AF26B5E84}">
       <p14:sectionLst xmlns:p14="http://schemas.microsoft.com/office/powerpoint/2010/main">
-        <p14:section name="Opening" id="{A69F651A-0699-8B69-5332-69B338E81964}">
+        <p14:section name="Opening" id="{4C6EC77D-A433-1D84-A2B4-6336DC6D72C1}">
           <p14:sldIdLst>
             <p14:sldId id="256"/>
           </p14:sldIdLst>
         </p14:section>
-        <p14:section name="Problem" id="{7F13BC76-DF15-4B4E-7AB8-5E8AEC9D1E28}">
+        <p14:section name="Problem" id="{F7873060-A489-67F0-B562-2D0FDEF90763}">
           <p14:sldIdLst>
             <p14:sldId id="257"/>
           </p14:sldIdLst>
         </p14:section>
-        <p14:section name="Objectives" id="{059723FC-5154-8016-A376-166240D01377}">
+        <p14:section name="Objectives" id="{3226DDB0-D8AE-C392-4DC8-EC6EE45926F7}">
           <p14:sldIdLst>
             <p14:sldId id="258"/>
           </p14:sldIdLst>
         </p14:section>
-        <p14:section name="Design" id="{5B0CEF3B-50CA-B99A-3104-08AAE7CDD4BE}">
+        <p14:section name="Design" id="{3CA05D98-437E-B99F-57FC-646B3E473F54}">
           <p14:sldIdLst>
             <p14:sldId id="259"/>
             <p14:sldId id="260"/>
           </p14:sldIdLst>
         </p14:section>
-        <p14:section name="Evaluation" id="{35A9079B-E30D-754B-D66F-FAC4DC90C65B}">
+        <p14:section name="Evaluation" id="{083AFFA7-243D-2DD2-C7DD-CC26BE13F1ED}">
           <p14:sldIdLst>
             <p14:sldId id="261"/>
             <p14:sldId id="262"/>
             <p14:sldId id="263"/>
           </p14:sldIdLst>
         </p14:section>
-        <p14:section name="Analysis" id="{6A44E519-9A53-30DF-8F5E-0F8998CC6163}">
+        <p14:section name="Analysis" id="{36B070BE-402A-6780-B27F-2E9C1B40A45D}">
           <p14:sldIdLst>
             <p14:sldId id="264"/>
           </p14:sldIdLst>
         </p14:section>
-        <p14:section name="Closing" id="{3905FFC7-E83C-1DC8-137F-27328F245735}">
+        <p14:section name="Closing" id="{F510F9E9-6720-1C9F-1255-090BFC2927E7}">
           <p14:sldIdLst>
             <p14:sldId id="265"/>
           </p14:sldIdLst>
@@ -277,7 +277,7 @@
           </c:val>
           <c:extLst>
             <c:ext xmlns:c16="http://schemas.microsoft.com/office/drawing/2014/chart" uri="{C3380CC4-5D6E-409C-BE32-E72D297353CC}">
-              <c16:uniqueId val="{00000000-6EB6-4177-A8D7-EDEE10CD701E}"/>
+              <c16:uniqueId val="{00000000-FBF0-402A-817A-8BDC0E9BCADB}"/>
             </c:ext>
           </c:extLst>
         </c:ser>
@@ -369,7 +369,7 @@
           </c:val>
           <c:extLst>
             <c:ext xmlns:c16="http://schemas.microsoft.com/office/drawing/2014/chart" uri="{C3380CC4-5D6E-409C-BE32-E72D297353CC}">
-              <c16:uniqueId val="{00000001-6EB6-4177-A8D7-EDEE10CD701E}"/>
+              <c16:uniqueId val="{00000001-FBF0-402A-817A-8BDC0E9BCADB}"/>
             </c:ext>
           </c:extLst>
         </c:ser>
@@ -1474,7 +1474,7 @@
           <c:smooth val="0"/>
           <c:extLst>
             <c:ext xmlns:c16="http://schemas.microsoft.com/office/drawing/2014/chart" uri="{C3380CC4-5D6E-409C-BE32-E72D297353CC}">
-              <c16:uniqueId val="{00000000-B7B8-4095-B87F-DB99F76963B0}"/>
+              <c16:uniqueId val="{00000000-04F8-4D66-B5FE-9B8E1E1DDDE4}"/>
             </c:ext>
           </c:extLst>
         </c:ser>
@@ -2431,7 +2431,7 @@
           <c:smooth val="0"/>
           <c:extLst>
             <c:ext xmlns:c16="http://schemas.microsoft.com/office/drawing/2014/chart" uri="{C3380CC4-5D6E-409C-BE32-E72D297353CC}">
-              <c16:uniqueId val="{00000001-B7B8-4095-B87F-DB99F76963B0}"/>
+              <c16:uniqueId val="{00000001-04F8-4D66-B5FE-9B8E1E1DDDE4}"/>
             </c:ext>
           </c:extLst>
         </c:ser>
@@ -3388,7 +3388,7 @@
           <c:smooth val="0"/>
           <c:extLst>
             <c:ext xmlns:c16="http://schemas.microsoft.com/office/drawing/2014/chart" uri="{C3380CC4-5D6E-409C-BE32-E72D297353CC}">
-              <c16:uniqueId val="{00000002-B7B8-4095-B87F-DB99F76963B0}"/>
+              <c16:uniqueId val="{00000002-04F8-4D66-B5FE-9B8E1E1DDDE4}"/>
             </c:ext>
           </c:extLst>
         </c:ser>
@@ -3757,7 +3757,7 @@
           </c:val>
           <c:extLst>
             <c:ext xmlns:c16="http://schemas.microsoft.com/office/drawing/2014/chart" uri="{C3380CC4-5D6E-409C-BE32-E72D297353CC}">
-              <c16:uniqueId val="{00000000-40B9-49E2-8684-1AEF20695950}"/>
+              <c16:uniqueId val="{00000000-CC0D-46F2-A7D3-52F71FBDB46F}"/>
             </c:ext>
           </c:extLst>
         </c:ser>
@@ -3901,7 +3901,7 @@
           </c:val>
           <c:extLst>
             <c:ext xmlns:c16="http://schemas.microsoft.com/office/drawing/2014/chart" uri="{C3380CC4-5D6E-409C-BE32-E72D297353CC}">
-              <c16:uniqueId val="{00000001-40B9-49E2-8684-1AEF20695950}"/>
+              <c16:uniqueId val="{00000001-CC0D-46F2-A7D3-52F71FBDB46F}"/>
             </c:ext>
           </c:extLst>
         </c:ser>
@@ -4185,7 +4185,7 @@
           <c:smooth val="0"/>
           <c:extLst>
             <c:ext xmlns:c16="http://schemas.microsoft.com/office/drawing/2014/chart" uri="{C3380CC4-5D6E-409C-BE32-E72D297353CC}">
-              <c16:uniqueId val="{00000000-870B-4363-B37F-1E8D8962E687}"/>
+              <c16:uniqueId val="{00000000-9066-4036-9DA1-250002C388A9}"/>
             </c:ext>
           </c:extLst>
         </c:ser>
@@ -4274,7 +4274,7 @@
           <c:smooth val="0"/>
           <c:extLst>
             <c:ext xmlns:c16="http://schemas.microsoft.com/office/drawing/2014/chart" uri="{C3380CC4-5D6E-409C-BE32-E72D297353CC}">
-              <c16:uniqueId val="{00000001-870B-4363-B37F-1E8D8962E687}"/>
+              <c16:uniqueId val="{00000001-9066-4036-9DA1-250002C388A9}"/>
             </c:ext>
           </c:extLst>
         </c:ser>
@@ -4363,7 +4363,7 @@
           <c:smooth val="0"/>
           <c:extLst>
             <c:ext xmlns:c16="http://schemas.microsoft.com/office/drawing/2014/chart" uri="{C3380CC4-5D6E-409C-BE32-E72D297353CC}">
-              <c16:uniqueId val="{00000002-870B-4363-B37F-1E8D8962E687}"/>
+              <c16:uniqueId val="{00000002-9066-4036-9DA1-250002C388A9}"/>
             </c:ext>
           </c:extLst>
         </c:ser>
@@ -4603,7 +4603,7 @@
     </p:spTree>
     <p:extLst>
       <p:ext uri="{BB962C8B-B14F-4D97-AF65-F5344CB8AC3E}">
-        <p14:creationId xmlns:p14="http://schemas.microsoft.com/office/powerpoint/2010/main" val="1796279385"/>
+        <p14:creationId xmlns:p14="http://schemas.microsoft.com/office/powerpoint/2010/main" val="3136710903"/>
       </p:ext>
     </p:extLst>
   </p:cSld>
@@ -5784,93 +5784,6 @@
           </a:p>
         </p:txBody>
       </p:sp>
-      <p:sp>
-        <p:nvSpPr>
-          <p:cNvPr id="5" name="Text 0"/>
-          <p:cNvSpPr/>
-          <p:nvPr/>
-        </p:nvSpPr>
-        <p:spPr>
-          <a:xfrm>
-            <a:off x="685800" y="6382512"/>
-            <a:ext cx="8229600" cy="228600"/>
-          </a:xfrm>
-          <a:prstGeom prst="rect">
-            <a:avLst/>
-          </a:prstGeom>
-          <a:noFill/>
-          <a:ln/>
-        </p:spPr>
-        <p:txBody>
-          <a:bodyPr wrap="square" lIns="0" tIns="0" rIns="0" bIns="0" rtlCol="0" anchor="ctr"/>
-          <a:lstStyle/>
-          <a:p>
-            <a:pPr marL="0" indent="0">
-              <a:buNone/>
-            </a:pPr>
-            <a:r>
-              <a:rPr lang="en-US" sz="900" dirty="0">
-                <a:solidFill>
-                  <a:srgbClr val="6B6862"/>
-                </a:solidFill>
-                <a:latin typeface="IBM Plex Mono" pitchFamily="34" charset="0"/>
-                <a:ea typeface="IBM Plex Mono" pitchFamily="34" charset="-122"/>
-                <a:cs typeface="IBM Plex Mono" pitchFamily="34" charset="-120"/>
-              </a:rPr>
-              <a:t>Adaptive scheduling for parallel N-body simulation  ·  PCAP [COURSE CODE]</a:t>
-            </a:r>
-            <a:endParaRPr lang="en-US" sz="900" dirty="0"/>
-          </a:p>
-        </p:txBody>
-      </p:sp>
-      <p:sp>
-        <p:nvSpPr>
-          <p:cNvPr id="25" name="Slide Number Placeholder 0"/>
-          <p:cNvSpPr>
-            <a:spLocks noGrp="1"/>
-          </p:cNvSpPr>
-          <p:nvPr>
-            <p:ph type="sldNum" sz="quarter" idx="4294967295"/>
-          </p:nvPr>
-        </p:nvSpPr>
-        <p:spPr>
-          <a:xfrm>
-            <a:off x="10957255" y="6382512"/>
-            <a:ext cx="548640" cy="228600"/>
-          </a:xfrm>
-          <a:prstGeom prst="rect">
-            <a:avLst/>
-          </a:prstGeom>
-          <a:extLst>
-            <a:ext uri="{C572A759-6A51-4108-AA02-DFA0A04FC94B}">
-              <ma14:wrappingTextBoxFlag xmlns:ma14="http://schemas.microsoft.com/office/mac/drawingml/2011/main" xmlns="" val="0"/>
-            </a:ext>
-          </a:extLst>
-        </p:spPr>
-        <p:txBody>
-          <a:bodyPr/>
-          <a:lstStyle>
-            <a:lvl1pPr>
-              <a:defRPr sz="900">
-                <a:solidFill>
-                  <a:srgbClr val="6B6862"/>
-                </a:solidFill>
-                <a:latin typeface="IBM Plex Mono"/>
-                <a:ea typeface="IBM Plex Mono"/>
-                <a:cs typeface="IBM Plex Mono"/>
-              </a:defRPr>
-            </a:lvl1pPr>
-          </a:lstStyle>
-          <a:p>
-            <a:pPr algn="r"/>
-            <a:fld id="{F7021451-1387-4CA6-816F-3879F97B5CBC}" type="slidenum">
-              <a:rPr lang="en-US" b="0"/>
-              <a:t>‹#›</a:t>
-            </a:fld>
-            <a:endParaRPr lang="en-US"/>
-          </a:p>
-        </p:txBody>
-      </p:sp>
     </p:spTree>
   </p:cSld>
   <p:clrMapOvr>
@@ -5934,54 +5847,6 @@
           <a:chExt cx="0" cy="0"/>
         </a:xfrm>
       </p:grpSpPr>
-      <p:sp>
-        <p:nvSpPr>
-          <p:cNvPr id="25" name="Slide Number Placeholder 0"/>
-          <p:cNvSpPr>
-            <a:spLocks noGrp="1"/>
-          </p:cNvSpPr>
-          <p:nvPr>
-            <p:ph type="sldNum" sz="quarter" idx="4294967295"/>
-          </p:nvPr>
-        </p:nvSpPr>
-        <p:spPr>
-          <a:xfrm>
-            <a:off x="10957255" y="6382512"/>
-            <a:ext cx="548640" cy="228600"/>
-          </a:xfrm>
-          <a:prstGeom prst="rect">
-            <a:avLst/>
-          </a:prstGeom>
-          <a:extLst>
-            <a:ext uri="{C572A759-6A51-4108-AA02-DFA0A04FC94B}">
-              <ma14:wrappingTextBoxFlag xmlns:ma14="http://schemas.microsoft.com/office/mac/drawingml/2011/main" xmlns="" val="0"/>
-            </a:ext>
-          </a:extLst>
-        </p:spPr>
-        <p:txBody>
-          <a:bodyPr/>
-          <a:lstStyle>
-            <a:lvl1pPr>
-              <a:defRPr sz="900">
-                <a:solidFill>
-                  <a:srgbClr val="6B6862"/>
-                </a:solidFill>
-                <a:latin typeface="IBM Plex Mono"/>
-                <a:ea typeface="IBM Plex Mono"/>
-                <a:cs typeface="IBM Plex Mono"/>
-              </a:defRPr>
-            </a:lvl1pPr>
-          </a:lstStyle>
-          <a:p>
-            <a:pPr algn="r"/>
-            <a:fld id="{F7021451-1387-4CA6-816F-3879F97B5CBC}" type="slidenum">
-              <a:rPr lang="en-US" b="0"/>
-              <a:t>‹#›</a:t>
-            </a:fld>
-            <a:endParaRPr lang="en-US"/>
-          </a:p>
-        </p:txBody>
-      </p:sp>
     </p:spTree>
   </p:cSld>
   <p:clrMap bg1="lt1" tx1="dk1" bg2="lt2" tx2="dk2" accent1="accent1" accent2="accent2" accent3="accent3" accent4="accent4" accent5="accent5" accent6="accent6" hlink="hlink" folHlink="folHlink"/>
@@ -7676,54 +7541,6 @@
           </a:p>
         </p:txBody>
       </p:sp>
-      <p:sp>
-        <p:nvSpPr>
-          <p:cNvPr id="25" name="Slide Number Placeholder 0"/>
-          <p:cNvSpPr>
-            <a:spLocks noGrp="1"/>
-          </p:cNvSpPr>
-          <p:nvPr>
-            <p:ph type="sldNum" sz="quarter" idx="4294967295"/>
-          </p:nvPr>
-        </p:nvSpPr>
-        <p:spPr>
-          <a:xfrm>
-            <a:off x="10957255" y="6382512"/>
-            <a:ext cx="548640" cy="228600"/>
-          </a:xfrm>
-          <a:prstGeom prst="rect">
-            <a:avLst/>
-          </a:prstGeom>
-          <a:extLst>
-            <a:ext uri="{C572A759-6A51-4108-AA02-DFA0A04FC94B}">
-              <ma14:wrappingTextBoxFlag xmlns:ma14="http://schemas.microsoft.com/office/mac/drawingml/2011/main" xmlns="" val="0"/>
-            </a:ext>
-          </a:extLst>
-        </p:spPr>
-        <p:txBody>
-          <a:bodyPr/>
-          <a:lstStyle>
-            <a:lvl1pPr>
-              <a:defRPr sz="900">
-                <a:solidFill>
-                  <a:srgbClr val="6B6862"/>
-                </a:solidFill>
-                <a:latin typeface="IBM Plex Mono"/>
-                <a:ea typeface="IBM Plex Mono"/>
-                <a:cs typeface="IBM Plex Mono"/>
-              </a:defRPr>
-            </a:lvl1pPr>
-          </a:lstStyle>
-          <a:p>
-            <a:pPr algn="r"/>
-            <a:fld id="{F7021451-1387-4CA6-816F-3879F97B5CBC}" type="slidenum">
-              <a:rPr lang="en-US" b="0"/>
-              <a:t>2</a:t>
-            </a:fld>
-            <a:endParaRPr lang="en-US"/>
-          </a:p>
-        </p:txBody>
-      </p:sp>
     </p:spTree>
   </p:cSld>
   <p:clrMapOvr>
@@ -9047,54 +8864,6 @@
           </a:ln>
         </p:spPr>
       </p:sp>
-      <p:sp>
-        <p:nvSpPr>
-          <p:cNvPr id="35" name="Slide Number Placeholder 0"/>
-          <p:cNvSpPr>
-            <a:spLocks noGrp="1"/>
-          </p:cNvSpPr>
-          <p:nvPr>
-            <p:ph type="sldNum" sz="quarter" idx="4294967295"/>
-          </p:nvPr>
-        </p:nvSpPr>
-        <p:spPr>
-          <a:xfrm>
-            <a:off x="10957255" y="6382512"/>
-            <a:ext cx="548640" cy="228600"/>
-          </a:xfrm>
-          <a:prstGeom prst="rect">
-            <a:avLst/>
-          </a:prstGeom>
-          <a:extLst>
-            <a:ext uri="{C572A759-6A51-4108-AA02-DFA0A04FC94B}">
-              <ma14:wrappingTextBoxFlag xmlns:ma14="http://schemas.microsoft.com/office/mac/drawingml/2011/main" xmlns="" val="0"/>
-            </a:ext>
-          </a:extLst>
-        </p:spPr>
-        <p:txBody>
-          <a:bodyPr/>
-          <a:lstStyle>
-            <a:lvl1pPr>
-              <a:defRPr sz="900">
-                <a:solidFill>
-                  <a:srgbClr val="6B6862"/>
-                </a:solidFill>
-                <a:latin typeface="IBM Plex Mono"/>
-                <a:ea typeface="IBM Plex Mono"/>
-                <a:cs typeface="IBM Plex Mono"/>
-              </a:defRPr>
-            </a:lvl1pPr>
-          </a:lstStyle>
-          <a:p>
-            <a:pPr algn="r"/>
-            <a:fld id="{F7021451-1387-4CA6-816F-3879F97B5CBC}" type="slidenum">
-              <a:rPr lang="en-US" b="0"/>
-              <a:t>3</a:t>
-            </a:fld>
-            <a:endParaRPr lang="en-US"/>
-          </a:p>
-        </p:txBody>
-      </p:sp>
     </p:spTree>
   </p:cSld>
   <p:clrMapOvr>
@@ -10768,54 +10537,6 @@
           </a:p>
         </p:txBody>
       </p:sp>
-      <p:sp>
-        <p:nvSpPr>
-          <p:cNvPr id="42" name="Slide Number Placeholder 0"/>
-          <p:cNvSpPr>
-            <a:spLocks noGrp="1"/>
-          </p:cNvSpPr>
-          <p:nvPr>
-            <p:ph type="sldNum" sz="quarter" idx="4294967295"/>
-          </p:nvPr>
-        </p:nvSpPr>
-        <p:spPr>
-          <a:xfrm>
-            <a:off x="10957255" y="6382512"/>
-            <a:ext cx="548640" cy="228600"/>
-          </a:xfrm>
-          <a:prstGeom prst="rect">
-            <a:avLst/>
-          </a:prstGeom>
-          <a:extLst>
-            <a:ext uri="{C572A759-6A51-4108-AA02-DFA0A04FC94B}">
-              <ma14:wrappingTextBoxFlag xmlns:ma14="http://schemas.microsoft.com/office/mac/drawingml/2011/main" xmlns="" val="0"/>
-            </a:ext>
-          </a:extLst>
-        </p:spPr>
-        <p:txBody>
-          <a:bodyPr/>
-          <a:lstStyle>
-            <a:lvl1pPr>
-              <a:defRPr sz="900">
-                <a:solidFill>
-                  <a:srgbClr val="6B6862"/>
-                </a:solidFill>
-                <a:latin typeface="IBM Plex Mono"/>
-                <a:ea typeface="IBM Plex Mono"/>
-                <a:cs typeface="IBM Plex Mono"/>
-              </a:defRPr>
-            </a:lvl1pPr>
-          </a:lstStyle>
-          <a:p>
-            <a:pPr algn="r"/>
-            <a:fld id="{F7021451-1387-4CA6-816F-3879F97B5CBC}" type="slidenum">
-              <a:rPr lang="en-US" b="0"/>
-              <a:t>4</a:t>
-            </a:fld>
-            <a:endParaRPr lang="en-US"/>
-          </a:p>
-        </p:txBody>
-      </p:sp>
     </p:spTree>
   </p:cSld>
   <p:clrMapOvr>
@@ -12062,54 +11783,6 @@
           </a:p>
         </p:txBody>
       </p:sp>
-      <p:sp>
-        <p:nvSpPr>
-          <p:cNvPr id="32" name="Slide Number Placeholder 0"/>
-          <p:cNvSpPr>
-            <a:spLocks noGrp="1"/>
-          </p:cNvSpPr>
-          <p:nvPr>
-            <p:ph type="sldNum" sz="quarter" idx="4294967295"/>
-          </p:nvPr>
-        </p:nvSpPr>
-        <p:spPr>
-          <a:xfrm>
-            <a:off x="10957255" y="6382512"/>
-            <a:ext cx="548640" cy="228600"/>
-          </a:xfrm>
-          <a:prstGeom prst="rect">
-            <a:avLst/>
-          </a:prstGeom>
-          <a:extLst>
-            <a:ext uri="{C572A759-6A51-4108-AA02-DFA0A04FC94B}">
-              <ma14:wrappingTextBoxFlag xmlns:ma14="http://schemas.microsoft.com/office/mac/drawingml/2011/main" xmlns="" val="0"/>
-            </a:ext>
-          </a:extLst>
-        </p:spPr>
-        <p:txBody>
-          <a:bodyPr/>
-          <a:lstStyle>
-            <a:lvl1pPr>
-              <a:defRPr sz="900">
-                <a:solidFill>
-                  <a:srgbClr val="6B6862"/>
-                </a:solidFill>
-                <a:latin typeface="IBM Plex Mono"/>
-                <a:ea typeface="IBM Plex Mono"/>
-                <a:cs typeface="IBM Plex Mono"/>
-              </a:defRPr>
-            </a:lvl1pPr>
-          </a:lstStyle>
-          <a:p>
-            <a:pPr algn="r"/>
-            <a:fld id="{F7021451-1387-4CA6-816F-3879F97B5CBC}" type="slidenum">
-              <a:rPr lang="en-US" b="0"/>
-              <a:t>5</a:t>
-            </a:fld>
-            <a:endParaRPr lang="en-US"/>
-          </a:p>
-        </p:txBody>
-      </p:sp>
     </p:spTree>
   </p:cSld>
   <p:clrMapOvr>
@@ -13327,54 +13000,6 @@
           </a:p>
         </p:txBody>
       </p:sp>
-      <p:sp>
-        <p:nvSpPr>
-          <p:cNvPr id="36" name="Slide Number Placeholder 0"/>
-          <p:cNvSpPr>
-            <a:spLocks noGrp="1"/>
-          </p:cNvSpPr>
-          <p:nvPr>
-            <p:ph type="sldNum" sz="quarter" idx="4294967295"/>
-          </p:nvPr>
-        </p:nvSpPr>
-        <p:spPr>
-          <a:xfrm>
-            <a:off x="10957255" y="6382512"/>
-            <a:ext cx="548640" cy="228600"/>
-          </a:xfrm>
-          <a:prstGeom prst="rect">
-            <a:avLst/>
-          </a:prstGeom>
-          <a:extLst>
-            <a:ext uri="{C572A759-6A51-4108-AA02-DFA0A04FC94B}">
-              <ma14:wrappingTextBoxFlag xmlns:ma14="http://schemas.microsoft.com/office/mac/drawingml/2011/main" xmlns="" val="0"/>
-            </a:ext>
-          </a:extLst>
-        </p:spPr>
-        <p:txBody>
-          <a:bodyPr/>
-          <a:lstStyle>
-            <a:lvl1pPr>
-              <a:defRPr sz="900">
-                <a:solidFill>
-                  <a:srgbClr val="6B6862"/>
-                </a:solidFill>
-                <a:latin typeface="IBM Plex Mono"/>
-                <a:ea typeface="IBM Plex Mono"/>
-                <a:cs typeface="IBM Plex Mono"/>
-              </a:defRPr>
-            </a:lvl1pPr>
-          </a:lstStyle>
-          <a:p>
-            <a:pPr algn="r"/>
-            <a:fld id="{F7021451-1387-4CA6-816F-3879F97B5CBC}" type="slidenum">
-              <a:rPr lang="en-US" b="0"/>
-              <a:t>6</a:t>
-            </a:fld>
-            <a:endParaRPr lang="en-US"/>
-          </a:p>
-        </p:txBody>
-      </p:sp>
     </p:spTree>
   </p:cSld>
   <p:clrMapOvr>
@@ -13924,54 +13549,6 @@
           </a:ln>
         </p:spPr>
       </p:sp>
-      <p:sp>
-        <p:nvSpPr>
-          <p:cNvPr id="25" name="Slide Number Placeholder 0"/>
-          <p:cNvSpPr>
-            <a:spLocks noGrp="1"/>
-          </p:cNvSpPr>
-          <p:nvPr>
-            <p:ph type="sldNum" sz="quarter" idx="4294967295"/>
-          </p:nvPr>
-        </p:nvSpPr>
-        <p:spPr>
-          <a:xfrm>
-            <a:off x="10957255" y="6382512"/>
-            <a:ext cx="548640" cy="228600"/>
-          </a:xfrm>
-          <a:prstGeom prst="rect">
-            <a:avLst/>
-          </a:prstGeom>
-          <a:extLst>
-            <a:ext uri="{C572A759-6A51-4108-AA02-DFA0A04FC94B}">
-              <ma14:wrappingTextBoxFlag xmlns:ma14="http://schemas.microsoft.com/office/mac/drawingml/2011/main" xmlns="" val="0"/>
-            </a:ext>
-          </a:extLst>
-        </p:spPr>
-        <p:txBody>
-          <a:bodyPr/>
-          <a:lstStyle>
-            <a:lvl1pPr>
-              <a:defRPr sz="900">
-                <a:solidFill>
-                  <a:srgbClr val="6B6862"/>
-                </a:solidFill>
-                <a:latin typeface="IBM Plex Mono"/>
-                <a:ea typeface="IBM Plex Mono"/>
-                <a:cs typeface="IBM Plex Mono"/>
-              </a:defRPr>
-            </a:lvl1pPr>
-          </a:lstStyle>
-          <a:p>
-            <a:pPr algn="r"/>
-            <a:fld id="{F7021451-1387-4CA6-816F-3879F97B5CBC}" type="slidenum">
-              <a:rPr lang="en-US" b="0"/>
-              <a:t>7</a:t>
-            </a:fld>
-            <a:endParaRPr lang="en-US"/>
-          </a:p>
-        </p:txBody>
-      </p:sp>
     </p:spTree>
   </p:cSld>
   <p:clrMapOvr>
@@ -14576,54 +14153,6 @@
           </a:p>
         </p:txBody>
       </p:sp>
-      <p:sp>
-        <p:nvSpPr>
-          <p:cNvPr id="25" name="Slide Number Placeholder 0"/>
-          <p:cNvSpPr>
-            <a:spLocks noGrp="1"/>
-          </p:cNvSpPr>
-          <p:nvPr>
-            <p:ph type="sldNum" sz="quarter" idx="4294967295"/>
-          </p:nvPr>
-        </p:nvSpPr>
-        <p:spPr>
-          <a:xfrm>
-            <a:off x="10957255" y="6382512"/>
-            <a:ext cx="548640" cy="228600"/>
-          </a:xfrm>
-          <a:prstGeom prst="rect">
-            <a:avLst/>
-          </a:prstGeom>
-          <a:extLst>
-            <a:ext uri="{C572A759-6A51-4108-AA02-DFA0A04FC94B}">
-              <ma14:wrappingTextBoxFlag xmlns:ma14="http://schemas.microsoft.com/office/mac/drawingml/2011/main" xmlns="" val="0"/>
-            </a:ext>
-          </a:extLst>
-        </p:spPr>
-        <p:txBody>
-          <a:bodyPr/>
-          <a:lstStyle>
-            <a:lvl1pPr>
-              <a:defRPr sz="900">
-                <a:solidFill>
-                  <a:srgbClr val="6B6862"/>
-                </a:solidFill>
-                <a:latin typeface="IBM Plex Mono"/>
-                <a:ea typeface="IBM Plex Mono"/>
-                <a:cs typeface="IBM Plex Mono"/>
-              </a:defRPr>
-            </a:lvl1pPr>
-          </a:lstStyle>
-          <a:p>
-            <a:pPr algn="r"/>
-            <a:fld id="{F7021451-1387-4CA6-816F-3879F97B5CBC}" type="slidenum">
-              <a:rPr lang="en-US" b="0"/>
-              <a:t>8</a:t>
-            </a:fld>
-            <a:endParaRPr lang="en-US"/>
-          </a:p>
-        </p:txBody>
-      </p:sp>
     </p:spTree>
   </p:cSld>
   <p:clrMapOvr>
@@ -15353,54 +14882,6 @@
             <a:prstDash val="solid"/>
           </a:ln>
         </p:spPr>
-      </p:sp>
-      <p:sp>
-        <p:nvSpPr>
-          <p:cNvPr id="25" name="Slide Number Placeholder 0"/>
-          <p:cNvSpPr>
-            <a:spLocks noGrp="1"/>
-          </p:cNvSpPr>
-          <p:nvPr>
-            <p:ph type="sldNum" sz="quarter" idx="4294967295"/>
-          </p:nvPr>
-        </p:nvSpPr>
-        <p:spPr>
-          <a:xfrm>
-            <a:off x="10957255" y="6382512"/>
-            <a:ext cx="548640" cy="228600"/>
-          </a:xfrm>
-          <a:prstGeom prst="rect">
-            <a:avLst/>
-          </a:prstGeom>
-          <a:extLst>
-            <a:ext uri="{C572A759-6A51-4108-AA02-DFA0A04FC94B}">
-              <ma14:wrappingTextBoxFlag xmlns:ma14="http://schemas.microsoft.com/office/mac/drawingml/2011/main" xmlns="" val="0"/>
-            </a:ext>
-          </a:extLst>
-        </p:spPr>
-        <p:txBody>
-          <a:bodyPr/>
-          <a:lstStyle>
-            <a:lvl1pPr>
-              <a:defRPr sz="900">
-                <a:solidFill>
-                  <a:srgbClr val="6B6862"/>
-                </a:solidFill>
-                <a:latin typeface="IBM Plex Mono"/>
-                <a:ea typeface="IBM Plex Mono"/>
-                <a:cs typeface="IBM Plex Mono"/>
-              </a:defRPr>
-            </a:lvl1pPr>
-          </a:lstStyle>
-          <a:p>
-            <a:pPr algn="r"/>
-            <a:fld id="{F7021451-1387-4CA6-816F-3879F97B5CBC}" type="slidenum">
-              <a:rPr lang="en-US" b="0"/>
-              <a:t>9</a:t>
-            </a:fld>
-            <a:endParaRPr lang="en-US"/>
-          </a:p>
-        </p:txBody>
       </p:sp>
     </p:spTree>
   </p:cSld>

</xml_diff>

<commit_message>
Add IEEE-format report; shorter parallel-focused team guide; deck cover
- report/PCAP_Report_IEEE.docx + .pdf: 5-page IEEE conference-format
  report (A4, two columns), built by report/build_report.js from the same
  extracted result data as the deck; figures from report/figs.py.
- Team guide rewritten: 4 pages, focused on the parallel approach (what
  was parallelised, why, measured benefit) with parallel-computing viva Q&A.
- Deck cover: Manipal Institute of Technology; guide and course-code
  placeholders removed.

Co-Authored-By: Claude Opus 5.5 <noreply@anthropic.com>
</commit_message>
<xml_diff>
--- a/presentation/PCAP_NBody_Adaptive_Scheduling.pptx
+++ b/presentation/PCAP_NBody_Adaptive_Scheduling.pptx
@@ -128,40 +128,40 @@
   <p:extLst>
     <p:ext uri="{521415D9-36F7-43E2-AB2F-B90AF26B5E84}">
       <p14:sectionLst xmlns:p14="http://schemas.microsoft.com/office/powerpoint/2010/main">
-        <p14:section name="Opening" id="{4C6EC77D-A433-1D84-A2B4-6336DC6D72C1}">
+        <p14:section name="Opening" id="{E4582D5E-580B-E43D-6CFE-ECB5A3103C2D}">
           <p14:sldIdLst>
             <p14:sldId id="256"/>
           </p14:sldIdLst>
         </p14:section>
-        <p14:section name="Problem" id="{F7873060-A489-67F0-B562-2D0FDEF90763}">
+        <p14:section name="Problem" id="{D9DA81D8-3416-3F1C-6098-EF27A28703F2}">
           <p14:sldIdLst>
             <p14:sldId id="257"/>
           </p14:sldIdLst>
         </p14:section>
-        <p14:section name="Objectives" id="{3226DDB0-D8AE-C392-4DC8-EC6EE45926F7}">
+        <p14:section name="Objectives" id="{05428834-D151-CF0E-EF95-AF3E54EDA582}">
           <p14:sldIdLst>
             <p14:sldId id="258"/>
           </p14:sldIdLst>
         </p14:section>
-        <p14:section name="Design" id="{3CA05D98-437E-B99F-57FC-646B3E473F54}">
+        <p14:section name="Design" id="{B95FC5E2-C9D6-CEE7-6548-4E66535D4C6A}">
           <p14:sldIdLst>
             <p14:sldId id="259"/>
             <p14:sldId id="260"/>
           </p14:sldIdLst>
         </p14:section>
-        <p14:section name="Evaluation" id="{083AFFA7-243D-2DD2-C7DD-CC26BE13F1ED}">
+        <p14:section name="Evaluation" id="{EFD1B1A1-487D-841E-CCC5-0288C5F91699}">
           <p14:sldIdLst>
             <p14:sldId id="261"/>
             <p14:sldId id="262"/>
             <p14:sldId id="263"/>
           </p14:sldIdLst>
         </p14:section>
-        <p14:section name="Analysis" id="{36B070BE-402A-6780-B27F-2E9C1B40A45D}">
+        <p14:section name="Analysis" id="{995190E9-BE91-E488-A0CD-301895D9DACD}">
           <p14:sldIdLst>
             <p14:sldId id="264"/>
           </p14:sldIdLst>
         </p14:section>
-        <p14:section name="Closing" id="{F510F9E9-6720-1C9F-1255-090BFC2927E7}">
+        <p14:section name="Closing" id="{BBA4F13C-9598-0E95-31B7-4969F98E0580}">
           <p14:sldIdLst>
             <p14:sldId id="265"/>
           </p14:sldIdLst>
@@ -277,7 +277,7 @@
           </c:val>
           <c:extLst>
             <c:ext xmlns:c16="http://schemas.microsoft.com/office/drawing/2014/chart" uri="{C3380CC4-5D6E-409C-BE32-E72D297353CC}">
-              <c16:uniqueId val="{00000000-FBF0-402A-817A-8BDC0E9BCADB}"/>
+              <c16:uniqueId val="{00000000-5B6C-48D5-BD1C-FE63517B02A1}"/>
             </c:ext>
           </c:extLst>
         </c:ser>
@@ -369,7 +369,7 @@
           </c:val>
           <c:extLst>
             <c:ext xmlns:c16="http://schemas.microsoft.com/office/drawing/2014/chart" uri="{C3380CC4-5D6E-409C-BE32-E72D297353CC}">
-              <c16:uniqueId val="{00000001-FBF0-402A-817A-8BDC0E9BCADB}"/>
+              <c16:uniqueId val="{00000001-5B6C-48D5-BD1C-FE63517B02A1}"/>
             </c:ext>
           </c:extLst>
         </c:ser>
@@ -1474,7 +1474,7 @@
           <c:smooth val="0"/>
           <c:extLst>
             <c:ext xmlns:c16="http://schemas.microsoft.com/office/drawing/2014/chart" uri="{C3380CC4-5D6E-409C-BE32-E72D297353CC}">
-              <c16:uniqueId val="{00000000-04F8-4D66-B5FE-9B8E1E1DDDE4}"/>
+              <c16:uniqueId val="{00000000-B23F-4B50-8655-3640B50A74AD}"/>
             </c:ext>
           </c:extLst>
         </c:ser>
@@ -2431,7 +2431,7 @@
           <c:smooth val="0"/>
           <c:extLst>
             <c:ext xmlns:c16="http://schemas.microsoft.com/office/drawing/2014/chart" uri="{C3380CC4-5D6E-409C-BE32-E72D297353CC}">
-              <c16:uniqueId val="{00000001-04F8-4D66-B5FE-9B8E1E1DDDE4}"/>
+              <c16:uniqueId val="{00000001-B23F-4B50-8655-3640B50A74AD}"/>
             </c:ext>
           </c:extLst>
         </c:ser>
@@ -3388,7 +3388,7 @@
           <c:smooth val="0"/>
           <c:extLst>
             <c:ext xmlns:c16="http://schemas.microsoft.com/office/drawing/2014/chart" uri="{C3380CC4-5D6E-409C-BE32-E72D297353CC}">
-              <c16:uniqueId val="{00000002-04F8-4D66-B5FE-9B8E1E1DDDE4}"/>
+              <c16:uniqueId val="{00000002-B23F-4B50-8655-3640B50A74AD}"/>
             </c:ext>
           </c:extLst>
         </c:ser>
@@ -3757,7 +3757,7 @@
           </c:val>
           <c:extLst>
             <c:ext xmlns:c16="http://schemas.microsoft.com/office/drawing/2014/chart" uri="{C3380CC4-5D6E-409C-BE32-E72D297353CC}">
-              <c16:uniqueId val="{00000000-CC0D-46F2-A7D3-52F71FBDB46F}"/>
+              <c16:uniqueId val="{00000000-3EC2-4D92-B32C-79EED0068F44}"/>
             </c:ext>
           </c:extLst>
         </c:ser>
@@ -3901,7 +3901,7 @@
           </c:val>
           <c:extLst>
             <c:ext xmlns:c16="http://schemas.microsoft.com/office/drawing/2014/chart" uri="{C3380CC4-5D6E-409C-BE32-E72D297353CC}">
-              <c16:uniqueId val="{00000001-CC0D-46F2-A7D3-52F71FBDB46F}"/>
+              <c16:uniqueId val="{00000001-3EC2-4D92-B32C-79EED0068F44}"/>
             </c:ext>
           </c:extLst>
         </c:ser>
@@ -4185,7 +4185,7 @@
           <c:smooth val="0"/>
           <c:extLst>
             <c:ext xmlns:c16="http://schemas.microsoft.com/office/drawing/2014/chart" uri="{C3380CC4-5D6E-409C-BE32-E72D297353CC}">
-              <c16:uniqueId val="{00000000-9066-4036-9DA1-250002C388A9}"/>
+              <c16:uniqueId val="{00000000-4483-4297-838B-DFA97E69BE9E}"/>
             </c:ext>
           </c:extLst>
         </c:ser>
@@ -4274,7 +4274,7 @@
           <c:smooth val="0"/>
           <c:extLst>
             <c:ext xmlns:c16="http://schemas.microsoft.com/office/drawing/2014/chart" uri="{C3380CC4-5D6E-409C-BE32-E72D297353CC}">
-              <c16:uniqueId val="{00000001-9066-4036-9DA1-250002C388A9}"/>
+              <c16:uniqueId val="{00000001-4483-4297-838B-DFA97E69BE9E}"/>
             </c:ext>
           </c:extLst>
         </c:ser>
@@ -4363,7 +4363,7 @@
           <c:smooth val="0"/>
           <c:extLst>
             <c:ext xmlns:c16="http://schemas.microsoft.com/office/drawing/2014/chart" uri="{C3380CC4-5D6E-409C-BE32-E72D297353CC}">
-              <c16:uniqueId val="{00000002-9066-4036-9DA1-250002C388A9}"/>
+              <c16:uniqueId val="{00000002-4483-4297-838B-DFA97E69BE9E}"/>
             </c:ext>
           </c:extLst>
         </c:ser>
@@ -4603,7 +4603,7 @@
     </p:spTree>
     <p:extLst>
       <p:ext uri="{BB962C8B-B14F-4D97-AF65-F5344CB8AC3E}">
-        <p14:creationId xmlns:p14="http://schemas.microsoft.com/office/powerpoint/2010/main" val="3136710903"/>
+        <p14:creationId xmlns:p14="http://schemas.microsoft.com/office/powerpoint/2010/main" val="2713199565"/>
       </p:ext>
     </p:extLst>
   </p:cSld>
@@ -6464,7 +6464,7 @@
                 <a:ea typeface="IBM Plex Mono" pitchFamily="34" charset="-122"/>
                 <a:cs typeface="IBM Plex Mono" pitchFamily="34" charset="-120"/>
               </a:rPr>
-              <a:t>Guide        [GUIDE / FACULTY NAME]</a:t>
+              <a:t>Manipal Institute of Technology</a:t>
             </a:r>
             <a:endParaRPr lang="en-US" sz="900" dirty="0"/>
           </a:p>
@@ -6484,27 +6484,7 @@
                 <a:ea typeface="IBM Plex Mono" pitchFamily="34" charset="-122"/>
                 <a:cs typeface="IBM Plex Mono" pitchFamily="34" charset="-120"/>
               </a:rPr>
-              <a:t>Institution  [INSTITUTION]</a:t>
-            </a:r>
-            <a:endParaRPr lang="en-US" sz="900" dirty="0"/>
-          </a:p>
-          <a:p>
-            <a:pPr marL="0" indent="0">
-              <a:lnSpc>
-                <a:spcPct val="115000"/>
-              </a:lnSpc>
-              <a:buNone/>
-            </a:pPr>
-            <a:r>
-              <a:rPr lang="en-US" sz="900" dirty="0">
-                <a:solidFill>
-                  <a:srgbClr val="B9B5AC"/>
-                </a:solidFill>
-                <a:latin typeface="IBM Plex Mono" pitchFamily="34" charset="0"/>
-                <a:ea typeface="IBM Plex Mono" pitchFamily="34" charset="-122"/>
-                <a:cs typeface="IBM Plex Mono" pitchFamily="34" charset="-120"/>
-              </a:rPr>
-              <a:t>Parallel Computing Architecture and Programming  ·  [COURSE CODE]</a:t>
+              <a:t>Parallel Computing Architecture and Programming</a:t>
             </a:r>
             <a:endParaRPr lang="en-US" sz="900" dirty="0"/>
           </a:p>

</xml_diff>